<commit_message>
Slides: sd-13-021..025 titles at 92/108 and the DevOps và CI/CD group on the cover
Co-Authored-By: Claude Opus 5.5 <noreply@anthropic.com>
Claude-Session: https://claude.ai/code/session_01TQmrJYLm4GPgtXpQaEk7ey
</commit_message>
<xml_diff>
--- a/system-design-101/vi/lessons/sd-13-021/slides/sd-13-021.pptx
+++ b/system-design-101/vi/lessons/sd-13-021/slides/sd-13-021.pptx
@@ -1799,17 +1799,17 @@
           <a:ln/>
         </p:spPr>
         <p:txBody>
-          <a:bodyPr wrap="square" lIns="0" tIns="66675" rIns="0" bIns="-66675" rtlCol="0" anchor="t"/>
+          <a:bodyPr wrap="square" lIns="0" tIns="72009" rIns="0" bIns="-72009" rtlCol="0" anchor="t"/>
           <a:lstStyle/>
           <a:p>
             <a:pPr algn="l" indent="0" marL="0">
               <a:lnSpc>
-                <a:spcPts val="7800"/>
+                <a:spcPts val="8424"/>
               </a:lnSpc>
               <a:buNone/>
             </a:pPr>
             <a:r>
-              <a:rPr lang="en-US" sz="7500" dirty="0" spc="4" kern="0">
+              <a:rPr lang="en-US" sz="8100" dirty="0" spc="6" kern="0">
                 <a:solidFill>
                   <a:srgbClr val="F3EEE3"/>
                 </a:solidFill>
@@ -1820,7 +1820,7 @@
               <a:t>Làm</a:t>
             </a:r>
             <a:r>
-              <a:rPr lang="en-US" sz="7500" dirty="0" spc="2" kern="0">
+              <a:rPr lang="en-US" sz="8100" dirty="0" spc="2" kern="0">
                 <a:solidFill>
                   <a:srgbClr val="F3EEE3"/>
                 </a:solidFill>
@@ -1831,7 +1831,7 @@
               <a:t> cho</a:t>
             </a:r>
             <a:r>
-              <a:rPr lang="en-US" sz="7500" dirty="0" spc="-12" kern="0">
+              <a:rPr lang="en-US" sz="8100" dirty="0" spc="-10" kern="0">
                 <a:solidFill>
                   <a:srgbClr val="F3EEE3"/>
                 </a:solidFill>
@@ -1842,7 +1842,7 @@
               <a:t> một</a:t>
             </a:r>
             <a:r>
-              <a:rPr lang="en-US" sz="7500" dirty="0" spc="-5" kern="0">
+              <a:rPr lang="en-US" sz="8100" dirty="0" spc="-7" kern="0">
                 <a:solidFill>
                   <a:srgbClr val="F3EEE3"/>
                 </a:solidFill>
@@ -1853,7 +1853,7 @@
               <a:t> request</a:t>
             </a:r>
             <a:r>
-              <a:rPr lang="en-US" sz="7500" dirty="0" spc="0" kern="0">
+              <a:rPr lang="en-US" sz="8100" dirty="0" spc="0" kern="0">
                 <a:solidFill>
                   <a:srgbClr val="F3EEE3"/>
                 </a:solidFill>
@@ -1864,7 +1864,7 @@
               <a:t> chậm</a:t>
             </a:r>
             <a:r>
-              <a:rPr lang="en-US" sz="7500" dirty="0" spc="8" kern="0">
+              <a:rPr lang="en-US" sz="8100" dirty="0" spc="9" kern="0">
                 <a:solidFill>
                   <a:srgbClr val="F3EEE3"/>
                 </a:solidFill>
@@ -1875,7 +1875,7 @@
               <a:t> truy</a:t>
             </a:r>
             <a:r>
-              <a:rPr lang="en-US" sz="7500" dirty="0" spc="-57" kern="0">
+              <a:rPr lang="en-US" sz="8100" dirty="0" spc="-59" kern="0">
                 <a:solidFill>
                   <a:srgbClr val="F3EEE3"/>
                 </a:solidFill>
@@ -1886,7 +1886,7 @@
               <a:t> vết</a:t>
             </a:r>
             <a:r>
-              <a:rPr lang="en-US" sz="7500" dirty="0" spc="-95" kern="0">
+              <a:rPr lang="en-US" sz="8100" dirty="0" spc="-105" kern="0">
                 <a:solidFill>
                   <a:srgbClr val="F3EEE3"/>
                 </a:solidFill>
@@ -1896,7 +1896,7 @@
               </a:rPr>
               <a:t> được</a:t>
             </a:r>
-            <a:endParaRPr lang="en-US" sz="7500" dirty="0"/>
+            <a:endParaRPr lang="en-US" sz="8100" dirty="0"/>
           </a:p>
         </p:txBody>
       </p:sp>
@@ -2138,7 +2138,7 @@
               <a:t> nhóm</a:t>
             </a:r>
             <a:r>
-              <a:rPr lang="en-US" sz="1650" dirty="0" spc="-3" kern="0">
+              <a:rPr lang="en-US" sz="1650" dirty="0" spc="-4" kern="0">
                 <a:solidFill>
                   <a:srgbClr val="9AA0B5"/>
                 </a:solidFill>
@@ -2146,10 +2146,10 @@
                 <a:ea typeface="Be Vietnam Pro" pitchFamily="34" charset="-122"/>
                 <a:cs typeface="Be Vietnam Pro" pitchFamily="34" charset="-120"/>
               </a:rPr>
-              <a:t> Quan</a:t>
-            </a:r>
-            <a:r>
-              <a:rPr lang="en-US" sz="1650" dirty="0" spc="-9" kern="0">
+              <a:t> DevOps</a:t>
+            </a:r>
+            <a:r>
+              <a:rPr lang="en-US" sz="1650" dirty="0" spc="-7" kern="0">
                 <a:solidFill>
                   <a:srgbClr val="9AA0B5"/>
                 </a:solidFill>
@@ -2157,7 +2157,7 @@
                 <a:ea typeface="Be Vietnam Pro" pitchFamily="34" charset="-122"/>
                 <a:cs typeface="Be Vietnam Pro" pitchFamily="34" charset="-120"/>
               </a:rPr>
-              <a:t> sát</a:t>
+              <a:t> và</a:t>
             </a:r>
             <a:r>
               <a:rPr lang="en-US" sz="1650" dirty="0" spc="3" kern="0">
@@ -2168,18 +2168,7 @@
                 <a:ea typeface="Be Vietnam Pro" pitchFamily="34" charset="-122"/>
                 <a:cs typeface="Be Vietnam Pro" pitchFamily="34" charset="-120"/>
               </a:rPr>
-              <a:t> hệ</a:t>
-            </a:r>
-            <a:r>
-              <a:rPr lang="en-US" sz="1650" dirty="0" spc="1" kern="0">
-                <a:solidFill>
-                  <a:srgbClr val="9AA0B5"/>
-                </a:solidFill>
-                <a:latin typeface="Be Vietnam Pro" pitchFamily="34" charset="0"/>
-                <a:ea typeface="Be Vietnam Pro" pitchFamily="34" charset="-122"/>
-                <a:cs typeface="Be Vietnam Pro" pitchFamily="34" charset="-120"/>
-              </a:rPr>
-              <a:t> thống</a:t>
+              <a:t> CI/CD</a:t>
             </a:r>
             <a:endParaRPr lang="en-US" sz="1650" dirty="0"/>
           </a:p>
@@ -5666,7 +5655,7 @@
         <p:spPr>
           <a:xfrm>
             <a:off x="914400" y="1333500"/>
-            <a:ext cx="16459200" cy="1143000"/>
+            <a:ext cx="16459200" cy="1047750"/>
           </a:xfrm>
           <a:prstGeom prst="rect">
             <a:avLst/>
@@ -5682,7 +5671,7 @@
               <a:buNone/>
             </a:pPr>
             <a:r>
-              <a:rPr lang="en-US" sz="6000" dirty="0" spc="3" kern="0">
+              <a:rPr lang="en-US" sz="6900" dirty="0" spc="3" kern="0">
                 <a:solidFill>
                   <a:srgbClr val="F3EEE3"/>
                 </a:solidFill>
@@ -5693,7 +5682,7 @@
               <a:t>Dịch</a:t>
             </a:r>
             <a:r>
-              <a:rPr lang="en-US" sz="6000" dirty="0" spc="4" kern="0">
+              <a:rPr lang="en-US" sz="6900" dirty="0" spc="0" kern="0">
                 <a:solidFill>
                   <a:srgbClr val="F3EEE3"/>
                 </a:solidFill>
@@ -5704,7 +5693,7 @@
               <a:t> vụ</a:t>
             </a:r>
             <a:r>
-              <a:rPr lang="en-US" sz="6000" dirty="0" spc="2" kern="0">
+              <a:rPr lang="en-US" sz="6900" dirty="0" spc="-2" kern="0">
                 <a:solidFill>
                   <a:srgbClr val="F3EEE3"/>
                 </a:solidFill>
@@ -5715,7 +5704,7 @@
               <a:t> có</a:t>
             </a:r>
             <a:r>
-              <a:rPr lang="en-US" sz="6000" dirty="0" spc="0" kern="0">
+              <a:rPr lang="en-US" sz="6900" dirty="0" spc="-51" kern="0">
                 <a:solidFill>
                   <a:srgbClr val="F3EEE3"/>
                 </a:solidFill>
@@ -5723,10 +5712,10 @@
                 <a:ea typeface="Bricolage Grotesque ExtraBold" pitchFamily="34" charset="-122"/>
                 <a:cs typeface="Bricolage Grotesque ExtraBold" pitchFamily="34" charset="-120"/>
               </a:rPr>
-              <a:t> thu</a:t>
-            </a:r>
-            <a:r>
-              <a:rPr lang="en-US" sz="6000" dirty="0" spc="-2" kern="0">
+              <a:t> vết</a:t>
+            </a:r>
+            <a:r>
+              <a:rPr lang="en-US" sz="6900" dirty="0" spc="8" kern="0">
                 <a:solidFill>
                   <a:srgbClr val="F3EEE3"/>
                 </a:solidFill>
@@ -5734,10 +5723,10 @@
                 <a:ea typeface="Bricolage Grotesque ExtraBold" pitchFamily="34" charset="-122"/>
                 <a:cs typeface="Bricolage Grotesque ExtraBold" pitchFamily="34" charset="-120"/>
               </a:rPr>
-              <a:t> thập</a:t>
-            </a:r>
-            <a:r>
-              <a:rPr lang="en-US" sz="6000" dirty="0" spc="-44" kern="0">
+              <a:t> truyền</a:t>
+            </a:r>
+            <a:r>
+              <a:rPr lang="en-US" sz="6900" dirty="0" spc="0" kern="0">
                 <a:solidFill>
                   <a:srgbClr val="F3EEE3"/>
                 </a:solidFill>
@@ -5745,10 +5734,10 @@
                 <a:ea typeface="Bricolage Grotesque ExtraBold" pitchFamily="34" charset="-122"/>
                 <a:cs typeface="Bricolage Grotesque ExtraBold" pitchFamily="34" charset="-120"/>
               </a:rPr>
-              <a:t> vết</a:t>
-            </a:r>
-            <a:r>
-              <a:rPr lang="en-US" sz="6000" dirty="0" spc="5" kern="0">
+              <a:t> ngữ</a:t>
+            </a:r>
+            <a:r>
+              <a:rPr lang="en-US" sz="6900" dirty="0" spc="1" kern="0">
                 <a:solidFill>
                   <a:srgbClr val="F3EEE3"/>
                 </a:solidFill>
@@ -5756,42 +5745,9 @@
                 <a:ea typeface="Bricolage Grotesque ExtraBold" pitchFamily="34" charset="-122"/>
                 <a:cs typeface="Bricolage Grotesque ExtraBold" pitchFamily="34" charset="-120"/>
               </a:rPr>
-              <a:t> truyền</a:t>
-            </a:r>
-            <a:r>
-              <a:rPr lang="en-US" sz="6000" dirty="0" spc="2" kern="0">
-                <a:solidFill>
-                  <a:srgbClr val="F3EEE3"/>
-                </a:solidFill>
-                <a:latin typeface="Bricolage Grotesque ExtraBold" pitchFamily="34" charset="0"/>
-                <a:ea typeface="Bricolage Grotesque ExtraBold" pitchFamily="34" charset="-122"/>
-                <a:cs typeface="Bricolage Grotesque ExtraBold" pitchFamily="34" charset="-120"/>
-              </a:rPr>
-              <a:t> tiếp</a:t>
-            </a:r>
-            <a:r>
-              <a:rPr lang="en-US" sz="6000" dirty="0" spc="-2" kern="0">
-                <a:solidFill>
-                  <a:srgbClr val="F3EEE3"/>
-                </a:solidFill>
-                <a:latin typeface="Bricolage Grotesque ExtraBold" pitchFamily="34" charset="0"/>
-                <a:ea typeface="Bricolage Grotesque ExtraBold" pitchFamily="34" charset="-122"/>
-                <a:cs typeface="Bricolage Grotesque ExtraBold" pitchFamily="34" charset="-120"/>
-              </a:rPr>
-              <a:t> ngữ</a:t>
-            </a:r>
-            <a:r>
-              <a:rPr lang="en-US" sz="6000" dirty="0" spc="0" kern="0">
-                <a:solidFill>
-                  <a:srgbClr val="F3EEE3"/>
-                </a:solidFill>
-                <a:latin typeface="Bricolage Grotesque ExtraBold" pitchFamily="34" charset="0"/>
-                <a:ea typeface="Bricolage Grotesque ExtraBold" pitchFamily="34" charset="-122"/>
-                <a:cs typeface="Bricolage Grotesque ExtraBold" pitchFamily="34" charset="-120"/>
-              </a:rPr>
               <a:t> cảnh</a:t>
             </a:r>
-            <a:endParaRPr lang="en-US" sz="6000" dirty="0"/>
+            <a:endParaRPr lang="en-US" sz="6900" dirty="0"/>
           </a:p>
         </p:txBody>
       </p:sp>
@@ -11300,7 +11256,7 @@
         <p:spPr>
           <a:xfrm>
             <a:off x="914400" y="1333500"/>
-            <a:ext cx="16459200" cy="1238250"/>
+            <a:ext cx="16459200" cy="1047750"/>
           </a:xfrm>
           <a:prstGeom prst="rect">
             <a:avLst/>
@@ -11316,7 +11272,7 @@
               <a:buNone/>
             </a:pPr>
             <a:r>
-              <a:rPr lang="en-US" sz="6600" dirty="0" spc="-1" kern="0">
+              <a:rPr lang="en-US" sz="6900" dirty="0" spc="1" kern="0">
                 <a:solidFill>
                   <a:srgbClr val="F3EEE3"/>
                 </a:solidFill>
@@ -11327,7 +11283,7 @@
               <a:t>Không</a:t>
             </a:r>
             <a:r>
-              <a:rPr lang="en-US" sz="6600" dirty="0" spc="3" kern="0">
+              <a:rPr lang="en-US" sz="6900" dirty="0" spc="0" kern="0">
                 <a:solidFill>
                   <a:srgbClr val="F3EEE3"/>
                 </a:solidFill>
@@ -11338,7 +11294,7 @@
               <a:t> bộ</a:t>
             </a:r>
             <a:r>
-              <a:rPr lang="en-US" sz="6600" dirty="0" spc="20" kern="0">
+              <a:rPr lang="en-US" sz="6900" dirty="0" spc="17" kern="0">
                 <a:solidFill>
                   <a:srgbClr val="F3EEE3"/>
                 </a:solidFill>
@@ -11349,7 +11305,7 @@
               <a:t> đo</a:t>
             </a:r>
             <a:r>
-              <a:rPr lang="en-US" sz="6600" dirty="0" spc="1" kern="0">
+              <a:rPr lang="en-US" sz="6900" dirty="0" spc="1" kern="0">
                 <a:solidFill>
                   <a:srgbClr val="F3EEE3"/>
                 </a:solidFill>
@@ -11360,7 +11316,7 @@
               <a:t> nào</a:t>
             </a:r>
             <a:r>
-              <a:rPr lang="en-US" sz="6600" dirty="0" spc="10" kern="0">
+              <a:rPr lang="en-US" sz="6900" dirty="0" spc="-43" kern="0">
                 <a:solidFill>
                   <a:srgbClr val="F3EEE3"/>
                 </a:solidFill>
@@ -11368,10 +11324,10 @@
                 <a:ea typeface="Bricolage Grotesque ExtraBold" pitchFamily="34" charset="-122"/>
                 <a:cs typeface="Bricolage Grotesque ExtraBold" pitchFamily="34" charset="-120"/>
               </a:rPr>
-              <a:t> đúng</a:t>
-            </a:r>
-            <a:r>
-              <a:rPr lang="en-US" sz="6600" dirty="0" spc="0" kern="0">
+              <a:t> hợp</a:t>
+            </a:r>
+            <a:r>
+              <a:rPr lang="en-US" sz="6900" dirty="0" spc="0" kern="0">
                 <a:solidFill>
                   <a:srgbClr val="F3EEE3"/>
                 </a:solidFill>
@@ -11379,10 +11335,10 @@
                 <a:ea typeface="Bricolage Grotesque ExtraBold" pitchFamily="34" charset="-122"/>
                 <a:cs typeface="Bricolage Grotesque ExtraBold" pitchFamily="34" charset="-120"/>
               </a:rPr>
-              <a:t> cho</a:t>
-            </a:r>
-            <a:r>
-              <a:rPr lang="en-US" sz="6600" dirty="0" spc="1" kern="0">
+              <a:t> mọi</a:t>
+            </a:r>
+            <a:r>
+              <a:rPr lang="en-US" sz="6900" dirty="0" spc="3" kern="0">
                 <a:solidFill>
                   <a:srgbClr val="F3EEE3"/>
                 </a:solidFill>
@@ -11390,10 +11346,10 @@
                 <a:ea typeface="Bricolage Grotesque ExtraBold" pitchFamily="34" charset="-122"/>
                 <a:cs typeface="Bricolage Grotesque ExtraBold" pitchFamily="34" charset="-120"/>
               </a:rPr>
-              <a:t> mọi</a:t>
-            </a:r>
-            <a:r>
-              <a:rPr lang="en-US" sz="6600" dirty="0" spc="-3" kern="0">
+              <a:t> hệ</a:t>
+            </a:r>
+            <a:r>
+              <a:rPr lang="en-US" sz="6900" dirty="0" spc="1" kern="0">
                 <a:solidFill>
                   <a:srgbClr val="F3EEE3"/>
                 </a:solidFill>
@@ -11401,20 +11357,9 @@
                 <a:ea typeface="Bricolage Grotesque ExtraBold" pitchFamily="34" charset="-122"/>
                 <a:cs typeface="Bricolage Grotesque ExtraBold" pitchFamily="34" charset="-120"/>
               </a:rPr>
-              <a:t> hệ</a:t>
-            </a:r>
-            <a:r>
-              <a:rPr lang="en-US" sz="6600" dirty="0" spc="1" kern="0">
-                <a:solidFill>
-                  <a:srgbClr val="F3EEE3"/>
-                </a:solidFill>
-                <a:latin typeface="Bricolage Grotesque ExtraBold" pitchFamily="34" charset="0"/>
-                <a:ea typeface="Bricolage Grotesque ExtraBold" pitchFamily="34" charset="-122"/>
-                <a:cs typeface="Bricolage Grotesque ExtraBold" pitchFamily="34" charset="-120"/>
-              </a:rPr>
               <a:t> thống</a:t>
             </a:r>
-            <a:endParaRPr lang="en-US" sz="6600" dirty="0"/>
+            <a:endParaRPr lang="en-US" sz="6900" dirty="0"/>
           </a:p>
         </p:txBody>
       </p:sp>
@@ -13893,7 +13838,7 @@
         <p:spPr>
           <a:xfrm>
             <a:off x="914400" y="1333500"/>
-            <a:ext cx="16459200" cy="1143000"/>
+            <a:ext cx="16459200" cy="1047750"/>
           </a:xfrm>
           <a:prstGeom prst="rect">
             <a:avLst/>
@@ -13909,7 +13854,7 @@
               <a:buNone/>
             </a:pPr>
             <a:r>
-              <a:rPr lang="en-US" sz="6600" dirty="0" spc="1" kern="0">
+              <a:rPr lang="en-US" sz="6900" dirty="0" spc="-1" kern="0">
                 <a:solidFill>
                   <a:srgbClr val="14161C"/>
                 </a:solidFill>
@@ -13920,7 +13865,7 @@
               <a:t>Bốn</a:t>
             </a:r>
             <a:r>
-              <a:rPr lang="en-US" sz="6600" dirty="0" spc="-3" kern="0">
+              <a:rPr lang="en-US" sz="6900" dirty="0" spc="0" kern="0">
                 <a:solidFill>
                   <a:srgbClr val="14161C"/>
                 </a:solidFill>
@@ -13931,7 +13876,7 @@
               <a:t> chi</a:t>
             </a:r>
             <a:r>
-              <a:rPr lang="en-US" sz="6600" dirty="0" spc="0" kern="0">
+              <a:rPr lang="en-US" sz="6900" dirty="0" spc="2" kern="0">
                 <a:solidFill>
                   <a:srgbClr val="14161C"/>
                 </a:solidFill>
@@ -13942,7 +13887,7 @@
               <a:t> tiết</a:t>
             </a:r>
             <a:r>
-              <a:rPr lang="en-US" sz="6600" dirty="0" spc="6" kern="0">
+              <a:rPr lang="en-US" sz="6900" dirty="0" spc="8" kern="0">
                 <a:solidFill>
                   <a:srgbClr val="14161C"/>
                 </a:solidFill>
@@ -13953,7 +13898,7 @@
               <a:t> đáng</a:t>
             </a:r>
             <a:r>
-              <a:rPr lang="en-US" sz="6600" dirty="0" spc="-1" kern="0">
+              <a:rPr lang="en-US" sz="6900" dirty="0" spc="1" kern="0">
                 <a:solidFill>
                   <a:srgbClr val="14161C"/>
                 </a:solidFill>
@@ -13963,7 +13908,7 @@
               </a:rPr>
               <a:t> nhớ</a:t>
             </a:r>
-            <a:endParaRPr lang="en-US" sz="6600" dirty="0"/>
+            <a:endParaRPr lang="en-US" sz="6900" dirty="0"/>
           </a:p>
         </p:txBody>
       </p:sp>

</xml_diff>

<commit_message>
Slides: sd-13-021..025 body text at 34 px; sd-13-025 commands as the lesson writes them
Co-Authored-By: Claude Opus 5.5 <noreply@anthropic.com>
Claude-Session: https://claude.ai/code/session_01TQmrJYLm4GPgtXpQaEk7ey
</commit_message>
<xml_diff>
--- a/system-design-101/vi/lessons/sd-13-021/slides/sd-13-021.pptx
+++ b/system-design-101/vi/lessons/sd-13-021/slides/sd-13-021.pptx
@@ -5860,7 +5860,7 @@
               <a:buNone/>
             </a:pPr>
             <a:r>
-              <a:rPr lang="en-US" sz="2250" dirty="0" spc="-4" kern="0">
+              <a:rPr lang="en-US" sz="2550" dirty="0" spc="-2" kern="0">
                 <a:solidFill>
                   <a:srgbClr val="E4E1D8"/>
                 </a:solidFill>
@@ -5871,7 +5871,7 @@
               <a:t>header</a:t>
             </a:r>
             <a:r>
-              <a:rPr lang="en-US" sz="2250" dirty="0" spc="-20" kern="0">
+              <a:rPr lang="en-US" sz="2550" dirty="0" spc="-21" kern="0">
                 <a:solidFill>
                   <a:srgbClr val="E4E1D8"/>
                 </a:solidFill>
@@ -5881,7 +5881,7 @@
               </a:rPr>
               <a:t> traceparent</a:t>
             </a:r>
-            <a:endParaRPr lang="en-US" sz="2250" dirty="0"/>
+            <a:endParaRPr lang="en-US" sz="2550" dirty="0"/>
           </a:p>
         </p:txBody>
       </p:sp>
@@ -5980,7 +5980,7 @@
               <a:buNone/>
             </a:pPr>
             <a:r>
-              <a:rPr lang="en-US" sz="2250" dirty="0" spc="-12" kern="0">
+              <a:rPr lang="en-US" sz="2550" dirty="0" spc="-12" kern="0">
                 <a:solidFill>
                   <a:srgbClr val="E4E1D8"/>
                 </a:solidFill>
@@ -5990,7 +5990,7 @@
               </a:rPr>
               <a:t>trace-id</a:t>
             </a:r>
-            <a:endParaRPr lang="en-US" sz="2250" dirty="0"/>
+            <a:endParaRPr lang="en-US" sz="2550" dirty="0"/>
           </a:p>
         </p:txBody>
       </p:sp>
@@ -6089,7 +6089,7 @@
               <a:buNone/>
             </a:pPr>
             <a:r>
-              <a:rPr lang="en-US" sz="2250" dirty="0" spc="-17" kern="0">
+              <a:rPr lang="en-US" sz="2550" dirty="0" spc="-18" kern="0">
                 <a:solidFill>
                   <a:srgbClr val="E4E1D8"/>
                 </a:solidFill>
@@ -6100,7 +6100,7 @@
               <a:t>parent-id</a:t>
             </a:r>
             <a:r>
-              <a:rPr lang="en-US" sz="2250" dirty="0" spc="3" kern="0">
+              <a:rPr lang="en-US" sz="2550" dirty="0" spc="-2" kern="0">
                 <a:solidFill>
                   <a:srgbClr val="E4E1D8"/>
                 </a:solidFill>
@@ -6111,7 +6111,7 @@
               <a:t> của</a:t>
             </a:r>
             <a:r>
-              <a:rPr lang="en-US" sz="2250" dirty="0" spc="0" kern="0">
+              <a:rPr lang="en-US" sz="2550" dirty="0" spc="1" kern="0">
                 <a:solidFill>
                   <a:srgbClr val="E4E1D8"/>
                 </a:solidFill>
@@ -6121,7 +6121,7 @@
               </a:rPr>
               <a:t> mình</a:t>
             </a:r>
-            <a:endParaRPr lang="en-US" sz="2250" dirty="0"/>
+            <a:endParaRPr lang="en-US" sz="2550" dirty="0"/>
           </a:p>
         </p:txBody>
       </p:sp>
@@ -6220,7 +6220,7 @@
               <a:buNone/>
             </a:pPr>
             <a:r>
-              <a:rPr lang="en-US" sz="2250" dirty="0" spc="-6" kern="0">
+              <a:rPr lang="en-US" sz="2550" dirty="0" spc="-7" kern="0">
                 <a:solidFill>
                   <a:srgbClr val="E4E1D8"/>
                 </a:solidFill>
@@ -6231,7 +6231,7 @@
               <a:t>sang</a:t>
             </a:r>
             <a:r>
-              <a:rPr lang="en-US" sz="2250" dirty="0" spc="2" kern="0">
+              <a:rPr lang="en-US" sz="2550" dirty="0" spc="0" kern="0">
                 <a:solidFill>
                   <a:srgbClr val="E4E1D8"/>
                 </a:solidFill>
@@ -6239,10 +6239,10 @@
                 <a:ea typeface="Be Vietnam Pro" pitchFamily="34" charset="-122"/>
                 <a:cs typeface="Be Vietnam Pro" pitchFamily="34" charset="-120"/>
               </a:rPr>
-              <a:t> dịch vụ</a:t>
-            </a:r>
-            <a:r>
-              <a:rPr lang="en-US" sz="2250" dirty="0" spc="-5" kern="0">
+              <a:t> dịch</a:t>
+            </a:r>
+            <a:r>
+              <a:rPr lang="en-US" sz="2550" dirty="0" spc="-4" kern="0">
                 <a:solidFill>
                   <a:srgbClr val="E4E1D8"/>
                 </a:solidFill>
@@ -6250,9 +6250,20 @@
                 <a:ea typeface="Be Vietnam Pro" pitchFamily="34" charset="-122"/>
                 <a:cs typeface="Be Vietnam Pro" pitchFamily="34" charset="-120"/>
               </a:rPr>
+              <a:t> vụ</a:t>
+            </a:r>
+            <a:r>
+              <a:rPr lang="en-US" sz="2550" dirty="0" spc="-6" kern="0">
+                <a:solidFill>
+                  <a:srgbClr val="E4E1D8"/>
+                </a:solidFill>
+                <a:latin typeface="Be Vietnam Pro" pitchFamily="34" charset="0"/>
+                <a:ea typeface="Be Vietnam Pro" pitchFamily="34" charset="-122"/>
+                <a:cs typeface="Be Vietnam Pro" pitchFamily="34" charset="-120"/>
+              </a:rPr>
               <a:t> sau</a:t>
             </a:r>
-            <a:endParaRPr lang="en-US" sz="2250" dirty="0"/>
+            <a:endParaRPr lang="en-US" sz="2550" dirty="0"/>
           </a:p>
         </p:txBody>
       </p:sp>
@@ -10277,12 +10288,12 @@
           <a:ln/>
         </p:spPr>
         <p:txBody>
-          <a:bodyPr wrap="square" lIns="0" tIns="5334" rIns="0" bIns="-5334" rtlCol="0" anchor="t"/>
+          <a:bodyPr wrap="square" lIns="0" tIns="5667" rIns="0" bIns="-5667" rtlCol="0" anchor="t"/>
           <a:lstStyle/>
           <a:p>
-            <a:pPr algn="l" marL="304800" indent="-217761">
+            <a:pPr algn="l" marL="323850" indent="-231371">
               <a:lnSpc>
-                <a:spcPts val="3360"/>
+                <a:spcPts val="3570"/>
               </a:lnSpc>
               <a:spcAft>
                 <a:spcPts val="600"/>
@@ -10292,7 +10303,7 @@
               <a:buChar char="•"/>
             </a:pPr>
             <a:r>
-              <a:rPr lang="en-US" sz="2400" dirty="0" spc="-23" kern="0">
+              <a:rPr lang="en-US" sz="2550" dirty="0" spc="-21" kern="0">
                 <a:solidFill>
                   <a:srgbClr val="14161C"/>
                 </a:solidFill>
@@ -10303,7 +10314,7 @@
               <a:t>Quyết</a:t>
             </a:r>
             <a:r>
-              <a:rPr lang="en-US" sz="2400" dirty="0" spc="20" kern="0">
+              <a:rPr lang="en-US" sz="2550" dirty="0" spc="20" kern="0">
                 <a:solidFill>
                   <a:srgbClr val="14161C"/>
                 </a:solidFill>
@@ -10314,7 +10325,7 @@
               <a:t> định</a:t>
             </a:r>
             <a:r>
-              <a:rPr lang="en-US" sz="2400" dirty="0" spc="-15" kern="0">
+              <a:rPr lang="en-US" sz="2550" dirty="0" spc="-18" kern="0">
                 <a:solidFill>
                   <a:srgbClr val="14161C"/>
                 </a:solidFill>
@@ -10325,7 +10336,7 @@
               <a:t> ngay</a:t>
             </a:r>
             <a:r>
-              <a:rPr lang="en-US" sz="2400" dirty="0" spc="4" kern="0">
+              <a:rPr lang="en-US" sz="2550" dirty="0" spc="-1" kern="0">
                 <a:solidFill>
                   <a:srgbClr val="14161C"/>
                 </a:solidFill>
@@ -10336,7 +10347,7 @@
               <a:t> từ</a:t>
             </a:r>
             <a:r>
-              <a:rPr lang="en-US" sz="2400" dirty="0" spc="10" kern="0">
+              <a:rPr lang="en-US" sz="2550" dirty="0" spc="13" kern="0">
                 <a:solidFill>
                   <a:srgbClr val="14161C"/>
                 </a:solidFill>
@@ -10346,41 +10357,41 @@
               </a:rPr>
               <a:t> đầu.</a:t>
             </a:r>
-            <a:endParaRPr lang="en-US" sz="2400" dirty="0"/>
+            <a:endParaRPr lang="en-US" sz="2550" dirty="0"/>
           </a:p>
           <a:p>
-            <a:pPr algn="l" marL="304800" indent="-217761">
+            <a:pPr algn="l" marL="323850" indent="-231371">
               <a:lnSpc>
-                <a:spcPts val="3360"/>
+                <a:spcPts val="3570"/>
               </a:lnSpc>
               <a:buSzPct val="100000"/>
               <a:buFont typeface="Arial"/>
               <a:buChar char="•"/>
             </a:pPr>
             <a:r>
-              <a:rPr lang="en-US" sz="2400" dirty="0" spc="2" kern="0">
-                <a:solidFill>
-                  <a:srgbClr val="14161C"/>
-                </a:solidFill>
-                <a:latin typeface="Be Vietnam Pro" pitchFamily="34" charset="0"/>
-                <a:ea typeface="Be Vietnam Pro" pitchFamily="34" charset="-122"/>
-                <a:cs typeface="Be Vietnam Pro" pitchFamily="34" charset="-120"/>
-              </a:rPr>
-              <a:t>Đơn giản,</a:t>
-            </a:r>
-            <a:r>
-              <a:rPr lang="en-US" sz="2400" dirty="0" spc="0" kern="0">
-                <a:solidFill>
-                  <a:srgbClr val="14161C"/>
-                </a:solidFill>
-                <a:latin typeface="Be Vietnam Pro" pitchFamily="34" charset="0"/>
-                <a:ea typeface="Be Vietnam Pro" pitchFamily="34" charset="-122"/>
-                <a:cs typeface="Be Vietnam Pro" pitchFamily="34" charset="-120"/>
-              </a:rPr>
-              <a:t> có</a:t>
-            </a:r>
-            <a:r>
-              <a:rPr lang="en-US" sz="2400" dirty="0" spc="1" kern="0">
+              <a:rPr lang="en-US" sz="2550" dirty="0" spc="-2" kern="0">
+                <a:solidFill>
+                  <a:srgbClr val="14161C"/>
+                </a:solidFill>
+                <a:latin typeface="Be Vietnam Pro" pitchFamily="34" charset="0"/>
+                <a:ea typeface="Be Vietnam Pro" pitchFamily="34" charset="-122"/>
+                <a:cs typeface="Be Vietnam Pro" pitchFamily="34" charset="-120"/>
+              </a:rPr>
+              <a:t>Đơn</a:t>
+            </a:r>
+            <a:r>
+              <a:rPr lang="en-US" sz="2550" dirty="0" spc="0" kern="0">
+                <a:solidFill>
+                  <a:srgbClr val="14161C"/>
+                </a:solidFill>
+                <a:latin typeface="Be Vietnam Pro" pitchFamily="34" charset="0"/>
+                <a:ea typeface="Be Vietnam Pro" pitchFamily="34" charset="-122"/>
+                <a:cs typeface="Be Vietnam Pro" pitchFamily="34" charset="-120"/>
+              </a:rPr>
+              <a:t> giản, có</a:t>
+            </a:r>
+            <a:r>
+              <a:rPr lang="en-US" sz="2550" dirty="0" spc="1" kern="0">
                 <a:solidFill>
                   <a:srgbClr val="14161C"/>
                 </a:solidFill>
@@ -10391,7 +10402,7 @@
               <a:t> thể</a:t>
             </a:r>
             <a:r>
-              <a:rPr lang="en-US" sz="2400" dirty="0" spc="-2" kern="0">
+              <a:rPr lang="en-US" sz="2550" dirty="0" spc="-4" kern="0">
                 <a:solidFill>
                   <a:srgbClr val="14161C"/>
                 </a:solidFill>
@@ -10402,7 +10413,7 @@
               <a:t> bỏ</a:t>
             </a:r>
             <a:r>
-              <a:rPr lang="en-US" sz="2400" dirty="0" spc="1" kern="0">
+              <a:rPr lang="en-US" sz="2550" dirty="0" spc="-1" kern="0">
                 <a:solidFill>
                   <a:srgbClr val="14161C"/>
                 </a:solidFill>
@@ -10413,7 +10424,7 @@
               <a:t> lỡ</a:t>
             </a:r>
             <a:r>
-              <a:rPr lang="en-US" sz="2400" dirty="0" spc="-18" kern="0">
+              <a:rPr lang="en-US" sz="2550" dirty="0" spc="-19" kern="0">
                 <a:solidFill>
                   <a:srgbClr val="14161C"/>
                 </a:solidFill>
@@ -10424,7 +10435,7 @@
               <a:t> vết</a:t>
             </a:r>
             <a:r>
-              <a:rPr lang="en-US" sz="2400" dirty="0" spc="0" kern="0">
+              <a:rPr lang="en-US" sz="2550" dirty="0" spc="0" kern="0">
                 <a:solidFill>
                   <a:srgbClr val="14161C"/>
                 </a:solidFill>
@@ -10434,7 +10445,7 @@
               </a:rPr>
               <a:t> lỗi.</a:t>
             </a:r>
-            <a:endParaRPr lang="en-US" sz="2400" dirty="0"/>
+            <a:endParaRPr lang="en-US" sz="2550" dirty="0"/>
           </a:p>
         </p:txBody>
       </p:sp>
@@ -10544,12 +10555,12 @@
           <a:ln/>
         </p:spPr>
         <p:txBody>
-          <a:bodyPr wrap="square" lIns="0" tIns="5334" rIns="0" bIns="-5334" rtlCol="0" anchor="t"/>
+          <a:bodyPr wrap="square" lIns="0" tIns="5667" rIns="0" bIns="-5667" rtlCol="0" anchor="t"/>
           <a:lstStyle/>
           <a:p>
-            <a:pPr algn="l" marL="304800" indent="-217761">
+            <a:pPr algn="l" marL="323850" indent="-231371">
               <a:lnSpc>
-                <a:spcPts val="3360"/>
+                <a:spcPts val="3570"/>
               </a:lnSpc>
               <a:spcAft>
                 <a:spcPts val="600"/>
@@ -10559,7 +10570,7 @@
               <a:buChar char="•"/>
             </a:pPr>
             <a:r>
-              <a:rPr lang="en-US" sz="2400" dirty="0" spc="-23" kern="0">
+              <a:rPr lang="en-US" sz="2550" dirty="0" spc="-21" kern="0">
                 <a:solidFill>
                   <a:srgbClr val="14161C"/>
                 </a:solidFill>
@@ -10570,7 +10581,7 @@
               <a:t>Quyết</a:t>
             </a:r>
             <a:r>
-              <a:rPr lang="en-US" sz="2400" dirty="0" spc="20" kern="0">
+              <a:rPr lang="en-US" sz="2550" dirty="0" spc="20" kern="0">
                 <a:solidFill>
                   <a:srgbClr val="14161C"/>
                 </a:solidFill>
@@ -10581,7 +10592,7 @@
               <a:t> định</a:t>
             </a:r>
             <a:r>
-              <a:rPr lang="en-US" sz="2400" dirty="0" spc="-7" kern="0">
+              <a:rPr lang="en-US" sz="2550" dirty="0" spc="-6" kern="0">
                 <a:solidFill>
                   <a:srgbClr val="14161C"/>
                 </a:solidFill>
@@ -10592,7 +10603,7 @@
               <a:t> sau</a:t>
             </a:r>
             <a:r>
-              <a:rPr lang="en-US" sz="2400" dirty="0" spc="-2" kern="0">
+              <a:rPr lang="en-US" sz="2550" dirty="0" spc="0" kern="0">
                 <a:solidFill>
                   <a:srgbClr val="14161C"/>
                 </a:solidFill>
@@ -10603,7 +10614,7 @@
               <a:t> khi</a:t>
             </a:r>
             <a:r>
-              <a:rPr lang="en-US" sz="2400" dirty="0" spc="-19" kern="0">
+              <a:rPr lang="en-US" sz="2550" dirty="0" spc="-20" kern="0">
                 <a:solidFill>
                   <a:srgbClr val="14161C"/>
                 </a:solidFill>
@@ -10614,7 +10625,7 @@
               <a:t> vết</a:t>
             </a:r>
             <a:r>
-              <a:rPr lang="en-US" sz="2400" dirty="0" spc="0" kern="0">
+              <a:rPr lang="en-US" sz="2550" dirty="0" spc="-2" kern="0">
                 <a:solidFill>
                   <a:srgbClr val="14161C"/>
                 </a:solidFill>
@@ -10625,7 +10636,7 @@
               <a:t> hoàn</a:t>
             </a:r>
             <a:r>
-              <a:rPr lang="en-US" sz="2400" dirty="0" spc="-17" kern="0">
+              <a:rPr lang="en-US" sz="2550" dirty="0" spc="-18" kern="0">
                 <a:solidFill>
                   <a:srgbClr val="14161C"/>
                 </a:solidFill>
@@ -10635,19 +10646,19 @@
               </a:rPr>
               <a:t> tất.</a:t>
             </a:r>
-            <a:endParaRPr lang="en-US" sz="2400" dirty="0"/>
+            <a:endParaRPr lang="en-US" sz="2550" dirty="0"/>
           </a:p>
           <a:p>
-            <a:pPr algn="l" marL="304800" indent="-217761">
+            <a:pPr algn="l" marL="323850" indent="-231371">
               <a:lnSpc>
-                <a:spcPts val="3360"/>
+                <a:spcPts val="3570"/>
               </a:lnSpc>
               <a:buSzPct val="100000"/>
               <a:buFont typeface="Arial"/>
               <a:buChar char="•"/>
             </a:pPr>
             <a:r>
-              <a:rPr lang="en-US" sz="2400" dirty="0" spc="2" kern="0">
+              <a:rPr lang="en-US" sz="2550" dirty="0" spc="-4" kern="0">
                 <a:solidFill>
                   <a:srgbClr val="14161C"/>
                 </a:solidFill>
@@ -10658,7 +10669,7 @@
               <a:t>Giữ</a:t>
             </a:r>
             <a:r>
-              <a:rPr lang="en-US" sz="2400" dirty="0" spc="7" kern="0">
+              <a:rPr lang="en-US" sz="2550" dirty="0" spc="7" kern="0">
                 <a:solidFill>
                   <a:srgbClr val="14161C"/>
                 </a:solidFill>
@@ -10669,7 +10680,7 @@
               <a:t> được</a:t>
             </a:r>
             <a:r>
-              <a:rPr lang="en-US" sz="2400" dirty="0" spc="-19" kern="0">
+              <a:rPr lang="en-US" sz="2550" dirty="0" spc="-20" kern="0">
                 <a:solidFill>
                   <a:srgbClr val="14161C"/>
                 </a:solidFill>
@@ -10680,7 +10691,7 @@
               <a:t> vết</a:t>
             </a:r>
             <a:r>
-              <a:rPr lang="en-US" sz="2400" dirty="0" spc="0" kern="0">
+              <a:rPr lang="en-US" sz="2550" dirty="0" spc="-1" kern="0">
                 <a:solidFill>
                   <a:srgbClr val="14161C"/>
                 </a:solidFill>
@@ -10691,7 +10702,7 @@
               <a:t> lỗi,</a:t>
             </a:r>
             <a:r>
-              <a:rPr lang="en-US" sz="2400" dirty="0" spc="2" kern="0">
+              <a:rPr lang="en-US" sz="2550" dirty="0" spc="1" kern="0">
                 <a:solidFill>
                   <a:srgbClr val="14161C"/>
                 </a:solidFill>
@@ -10702,7 +10713,7 @@
               <a:t> chậm;</a:t>
             </a:r>
             <a:r>
-              <a:rPr lang="en-US" sz="2400" dirty="0" spc="-10" kern="0">
+              <a:rPr lang="en-US" sz="2550" dirty="0" spc="-13" kern="0">
                 <a:solidFill>
                   <a:srgbClr val="14161C"/>
                 </a:solidFill>
@@ -10713,29 +10724,18 @@
               <a:t> tốn</a:t>
             </a:r>
             <a:r>
-              <a:rPr lang="en-US" sz="2400" dirty="0" spc="-11" kern="0">
-                <a:solidFill>
-                  <a:srgbClr val="14161C"/>
-                </a:solidFill>
-                <a:latin typeface="Be Vietnam Pro" pitchFamily="34" charset="0"/>
-                <a:ea typeface="Be Vietnam Pro" pitchFamily="34" charset="-122"/>
-                <a:cs typeface="Be Vietnam Pro" pitchFamily="34" charset="-120"/>
-              </a:rPr>
-              <a:t> tài</a:t>
-            </a:r>
-            <a:r>
-              <a:rPr lang="en-US" sz="2400" dirty="0" spc="-12" kern="0">
-                <a:solidFill>
-                  <a:srgbClr val="14161C"/>
-                </a:solidFill>
-                <a:latin typeface="Be Vietnam Pro" pitchFamily="34" charset="0"/>
-                <a:ea typeface="Be Vietnam Pro" pitchFamily="34" charset="-122"/>
-                <a:cs typeface="Be Vietnam Pro" pitchFamily="34" charset="-120"/>
-              </a:rPr>
-              <a:t> nguyên</a:t>
-            </a:r>
-            <a:r>
-              <a:rPr lang="en-US" sz="2400" dirty="0" spc="1" kern="0">
+              <a:rPr lang="en-US" sz="2550" dirty="0" spc="-12" kern="0">
+                <a:solidFill>
+                  <a:srgbClr val="14161C"/>
+                </a:solidFill>
+                <a:latin typeface="Be Vietnam Pro" pitchFamily="34" charset="0"/>
+                <a:ea typeface="Be Vietnam Pro" pitchFamily="34" charset="-122"/>
+                <a:cs typeface="Be Vietnam Pro" pitchFamily="34" charset="-120"/>
+              </a:rPr>
+              <a:t> tài nguyên</a:t>
+            </a:r>
+            <a:r>
+              <a:rPr lang="en-US" sz="2550" dirty="0" spc="1" kern="0">
                 <a:solidFill>
                   <a:srgbClr val="14161C"/>
                 </a:solidFill>
@@ -10745,7 +10745,7 @@
               </a:rPr>
               <a:t> hơn.</a:t>
             </a:r>
-            <a:endParaRPr lang="en-US" sz="2400" dirty="0"/>
+            <a:endParaRPr lang="en-US" sz="2550" dirty="0"/>
           </a:p>
         </p:txBody>
       </p:sp>

</xml_diff>